<commit_message>
Link the GitHub repository from the deck
Slide 6's "Source Code Repository" entry is now a real hyperlink, with the URL
shown beneath it so the address is readable in print as well as clickable. The
URL is taken from the repository's own origin remote, and build_deck.py gained
hyperlink support for the remaining Project Links entries.

Verified the link survives into the exported PDF as a /URI annotation, not just
in the PPTX.

Co-Authored-By: Claude Opus 5 <noreply@anthropic.com>
</commit_message>
<xml_diff>
--- a/SIH2026_26037_Idea.pptx
+++ b/SIH2026_26037_Idea.pptx
@@ -17214,19 +17214,39 @@
           <a:p>
             <a:pPr algn="l">
               <a:spcAft>
+                <a:spcPts val="100"/>
+              </a:spcAft>
+            </a:pPr>
+            <a:r>
+              <a:rPr sz="1200" b="1" i="0" u="sng">
+                <a:solidFill>
+                  <a:srgbClr val="1565C0"/>
+                </a:solidFill>
+                <a:latin typeface="Calibri"/>
+                <a:hlinkClick r:id="rId8"/>
+                <a:ea typeface="Calibri"/>
+                <a:cs typeface="Calibri"/>
+              </a:rPr>
+              <a:t>1) Source Code Repository</a:t>
+            </a:r>
+          </a:p>
+          <a:p>
+            <a:pPr algn="l">
+              <a:spcAft>
                 <a:spcPts val="500"/>
               </a:spcAft>
             </a:pPr>
             <a:r>
-              <a:rPr sz="1200" b="1" i="0" u="sng">
-                <a:solidFill>
-                  <a:srgbClr val="1565C0"/>
+              <a:rPr sz="800" b="0" i="0">
+                <a:solidFill>
+                  <a:srgbClr val="555555"/>
                 </a:solidFill>
                 <a:latin typeface="Calibri"/>
+                <a:hlinkClick r:id="rId8"/>
                 <a:ea typeface="Calibri"/>
                 <a:cs typeface="Calibri"/>
               </a:rPr>
-              <a:t>1) Source Code Repository</a:t>
+              <a:t>github.com/FX-at-Dev/Adaptive-Lane-Free-Path-Planning---Collision-Avoidance-for-Indian-Roads</a:t>
             </a:r>
           </a:p>
           <a:p>

</xml_diff>